<commit_message>
Retheme Vishvaksen's offshore-wind deck: teal-green -> ocean/sky blue accent, Trebuchet MS -> Century Gothic (more on-theme, distinct from the teal cluster)
</commit_message>
<xml_diff>
--- a/ppt/X25173421_offshore-wind-farm.pptx
+++ b/ppt/X25173421_offshore-wind-farm.pptx
@@ -3108,7 +3108,7 @@
             <a:avLst/>
           </a:prstGeom>
           <a:solidFill>
-            <a:srgbClr val="1F7A6F"/>
+            <a:srgbClr val="12689E"/>
           </a:solidFill>
           <a:ln>
             <a:noFill/>
@@ -3165,7 +3165,7 @@
                 <a:solidFill>
                   <a:srgbClr val="FFFFFF"/>
                 </a:solidFill>
-                <a:latin typeface="Trebuchet MS"/>
+                <a:latin typeface="Century Gothic"/>
               </a:rPr>
               <a:t>Offshore Wind Farm Turbine Monitoring</a:t>
             </a:r>
@@ -3198,7 +3198,7 @@
             <a:r>
               <a:rPr sz="1800" b="0" i="1">
                 <a:solidFill>
-                  <a:srgbClr val="C7DDDB"/>
+                  <a:srgbClr val="C3D9E6"/>
                 </a:solidFill>
                 <a:latin typeface="Calibri"/>
               </a:rPr>
@@ -3222,7 +3222,7 @@
             <a:avLst/>
           </a:prstGeom>
           <a:solidFill>
-            <a:srgbClr val="134B44"/>
+            <a:srgbClr val="0B4061"/>
           </a:solidFill>
           <a:ln>
             <a:noFill/>
@@ -3289,7 +3289,7 @@
             <a:r>
               <a:rPr sz="1300" b="0" i="0">
                 <a:solidFill>
-                  <a:srgbClr val="C0D9D6"/>
+                  <a:srgbClr val="BCD4E3"/>
                 </a:solidFill>
                 <a:latin typeface="Calibri"/>
               </a:rPr>
@@ -3301,7 +3301,7 @@
             <a:r>
               <a:rPr sz="1250" b="0" i="0">
                 <a:solidFill>
-                  <a:srgbClr val="C0D9D6"/>
+                  <a:srgbClr val="BCD4E3"/>
                 </a:solidFill>
                 <a:latin typeface="Calibri"/>
               </a:rPr>
@@ -3313,7 +3313,7 @@
             <a:r>
               <a:rPr sz="1250" b="0" i="0">
                 <a:solidFill>
-                  <a:srgbClr val="C0D9D6"/>
+                  <a:srgbClr val="BCD4E3"/>
                 </a:solidFill>
                 <a:latin typeface="Calibri"/>
               </a:rPr>
@@ -3408,9 +3408,9 @@
             <a:r>
               <a:rPr b="1" sz="2700">
                 <a:solidFill>
-                  <a:srgbClr val="7DB1AB"/>
-                </a:solidFill>
-                <a:latin typeface="Trebuchet MS"/>
+                  <a:srgbClr val="75A7C6"/>
+                </a:solidFill>
+                <a:latin typeface="Century Gothic"/>
               </a:rPr>
               <a:t>Why Periodic Inspection Fails Offshore</a:t>
             </a:r>
@@ -3511,7 +3511,7 @@
             <a:r>
               <a:rPr sz="1700" b="1">
                 <a:solidFill>
-                  <a:srgbClr val="7DB1AB"/>
+                  <a:srgbClr val="75A7C6"/>
                 </a:solidFill>
                 <a:latin typeface="Calibri"/>
               </a:rPr>
@@ -3535,7 +3535,7 @@
             <a:avLst/>
           </a:prstGeom>
           <a:solidFill>
-            <a:srgbClr val="7DB1AB"/>
+            <a:srgbClr val="75A7C6"/>
           </a:solidFill>
           <a:ln>
             <a:noFill/>
@@ -3650,9 +3650,9 @@
             <a:r>
               <a:rPr b="1" sz="2700">
                 <a:solidFill>
-                  <a:srgbClr val="7DB1AB"/>
-                </a:solidFill>
-                <a:latin typeface="Trebuchet MS"/>
+                  <a:srgbClr val="75A7C6"/>
+                </a:solidFill>
+                <a:latin typeface="Century Gothic"/>
               </a:rPr>
               <a:t>How It Works: Sensor to Live Dashboard</a:t>
             </a:r>
@@ -3689,7 +3689,7 @@
             <a:r>
               <a:rPr sz="1500" b="1">
                 <a:solidFill>
-                  <a:srgbClr val="7DB1AB"/>
+                  <a:srgbClr val="75A7C6"/>
                 </a:solidFill>
                 <a:latin typeface="Calibri"/>
               </a:rPr>
@@ -3721,7 +3721,7 @@
             <a:r>
               <a:rPr sz="1500" b="1">
                 <a:solidFill>
-                  <a:srgbClr val="7DB1AB"/>
+                  <a:srgbClr val="75A7C6"/>
                 </a:solidFill>
                 <a:latin typeface="Calibri"/>
               </a:rPr>
@@ -3793,7 +3793,7 @@
             <a:avLst/>
           </a:prstGeom>
           <a:solidFill>
-            <a:srgbClr val="7DB1AB"/>
+            <a:srgbClr val="75A7C6"/>
           </a:solidFill>
           <a:ln>
             <a:noFill/>
@@ -3932,9 +3932,9 @@
             <a:r>
               <a:rPr b="1" sz="2700">
                 <a:solidFill>
-                  <a:srgbClr val="7DB1AB"/>
-                </a:solidFill>
-                <a:latin typeface="Trebuchet MS"/>
+                  <a:srgbClr val="75A7C6"/>
+                </a:solidFill>
+                <a:latin typeface="Century Gothic"/>
               </a:rPr>
               <a:t>Live on AWS: Demonstration Highlights</a:t>
             </a:r>
@@ -3987,7 +3987,7 @@
             <a:r>
               <a:rPr sz="1500" b="1">
                 <a:solidFill>
-                  <a:srgbClr val="7DB1AB"/>
+                  <a:srgbClr val="75A7C6"/>
                 </a:solidFill>
                 <a:latin typeface="Calibri"/>
               </a:rPr>
@@ -4043,7 +4043,7 @@
             <a:avLst/>
           </a:prstGeom>
           <a:solidFill>
-            <a:srgbClr val="7DB1AB"/>
+            <a:srgbClr val="75A7C6"/>
           </a:solidFill>
           <a:ln>
             <a:noFill/>
@@ -4182,9 +4182,9 @@
             <a:r>
               <a:rPr b="1" sz="2700">
                 <a:solidFill>
-                  <a:srgbClr val="7DB1AB"/>
-                </a:solidFill>
-                <a:latin typeface="Trebuchet MS"/>
+                  <a:srgbClr val="75A7C6"/>
+                </a:solidFill>
+                <a:latin typeface="Century Gothic"/>
               </a:rPr>
               <a:t>Hardest Part: The Credential Trap</a:t>
             </a:r>
@@ -4221,7 +4221,7 @@
             <a:r>
               <a:rPr sz="1700" b="1">
                 <a:solidFill>
-                  <a:srgbClr val="7DB1AB"/>
+                  <a:srgbClr val="75A7C6"/>
                 </a:solidFill>
                 <a:latin typeface="Calibri"/>
               </a:rPr>
@@ -4253,7 +4253,7 @@
             <a:r>
               <a:rPr sz="1700" b="1">
                 <a:solidFill>
-                  <a:srgbClr val="7DB1AB"/>
+                  <a:srgbClr val="75A7C6"/>
                 </a:solidFill>
                 <a:latin typeface="Calibri"/>
               </a:rPr>
@@ -4285,7 +4285,7 @@
             <a:r>
               <a:rPr sz="1700" b="1">
                 <a:solidFill>
-                  <a:srgbClr val="7DB1AB"/>
+                  <a:srgbClr val="75A7C6"/>
                 </a:solidFill>
                 <a:latin typeface="Calibri"/>
               </a:rPr>
@@ -4341,7 +4341,7 @@
             <a:avLst/>
           </a:prstGeom>
           <a:solidFill>
-            <a:srgbClr val="7DB1AB"/>
+            <a:srgbClr val="75A7C6"/>
           </a:solidFill>
           <a:ln>
             <a:noFill/>
@@ -4456,9 +4456,9 @@
             <a:r>
               <a:rPr b="1" sz="2700">
                 <a:solidFill>
-                  <a:srgbClr val="7DB1AB"/>
-                </a:solidFill>
-                <a:latin typeface="Trebuchet MS"/>
+                  <a:srgbClr val="75A7C6"/>
+                </a:solidFill>
+                <a:latin typeface="Century Gothic"/>
               </a:rPr>
               <a:t>Three Things Worth Remembering</a:t>
             </a:r>
@@ -4527,7 +4527,7 @@
             <a:r>
               <a:rPr sz="1700" b="1">
                 <a:solidFill>
-                  <a:srgbClr val="7DB1AB"/>
+                  <a:srgbClr val="75A7C6"/>
                 </a:solidFill>
                 <a:latin typeface="Calibri"/>
               </a:rPr>
@@ -4567,7 +4567,7 @@
             <a:avLst/>
           </a:prstGeom>
           <a:solidFill>
-            <a:srgbClr val="7DB1AB"/>
+            <a:srgbClr val="75A7C6"/>
           </a:solidFill>
           <a:ln>
             <a:noFill/>

</xml_diff>

<commit_message>
Vishvaksen deck: move content off the dark archetype to a light band layout so its background no longer matches Gopi's marine-vessel deck
</commit_message>
<xml_diff>
--- a/ppt/X25173421_offshore-wind-farm.pptx
+++ b/ppt/X25173421_offshore-wind-farm.pptx
@@ -3348,14 +3348,14 @@
         </p:nvSpPr>
         <p:spPr>
           <a:xfrm>
-            <a:off x="-45720" y="-45720"/>
-            <a:ext cx="12344400" cy="6949440"/>
+            <a:off x="0" y="0"/>
+            <a:ext cx="12191695" cy="1051560"/>
           </a:xfrm>
           <a:prstGeom prst="rect">
             <a:avLst/>
           </a:prstGeom>
           <a:solidFill>
-            <a:srgbClr val="1B2024"/>
+            <a:srgbClr val="12689E"/>
           </a:solidFill>
           <a:ln>
             <a:noFill/>
@@ -3396,19 +3396,19 @@
         </p:nvSpPr>
         <p:spPr>
           <a:xfrm>
-            <a:off x="640080" y="384048"/>
-            <a:ext cx="10972800" cy="868680"/>
+            <a:off x="640080" y="0"/>
+            <a:ext cx="10972800" cy="1051560"/>
           </a:xfrm>
         </p:spPr>
         <p:txBody>
-          <a:bodyPr wrap="square" anchor="t"/>
+          <a:bodyPr wrap="square" anchor="ctr"/>
           <a:lstStyle/>
           <a:p>
             <a:pPr algn="l"/>
             <a:r>
-              <a:rPr b="1" sz="2700">
-                <a:solidFill>
-                  <a:srgbClr val="75A7C6"/>
+              <a:rPr b="1" sz="2400">
+                <a:solidFill>
+                  <a:srgbClr val="FFFFFF"/>
                 </a:solidFill>
                 <a:latin typeface="Century Gothic"/>
               </a:rPr>
@@ -3429,8 +3429,8 @@
         </p:nvSpPr>
         <p:spPr>
           <a:xfrm>
-            <a:off x="658368" y="1481328"/>
-            <a:ext cx="10972800" cy="4846320"/>
+            <a:off x="658368" y="1371600"/>
+            <a:ext cx="10972800" cy="5029200"/>
           </a:xfrm>
         </p:spPr>
         <p:txBody>
@@ -3447,7 +3447,7 @@
             <a:r>
               <a:rPr sz="1700" b="0">
                 <a:solidFill>
-                  <a:srgbClr val="E6EBE8"/>
+                  <a:srgbClr val="232A26"/>
                 </a:solidFill>
                 <a:latin typeface="Calibri"/>
               </a:rPr>
@@ -3463,7 +3463,7 @@
             <a:r>
               <a:rPr sz="1700" b="0">
                 <a:solidFill>
-                  <a:srgbClr val="E6EBE8"/>
+                  <a:srgbClr val="232A26"/>
                 </a:solidFill>
                 <a:latin typeface="Calibri"/>
               </a:rPr>
@@ -3479,7 +3479,7 @@
             <a:r>
               <a:rPr sz="1700" b="0">
                 <a:solidFill>
-                  <a:srgbClr val="E6EBE8"/>
+                  <a:srgbClr val="232A26"/>
                 </a:solidFill>
                 <a:latin typeface="Calibri"/>
               </a:rPr>
@@ -3495,7 +3495,7 @@
             <a:r>
               <a:rPr sz="1700" b="0">
                 <a:solidFill>
-                  <a:srgbClr val="E6EBE8"/>
+                  <a:srgbClr val="232A26"/>
                 </a:solidFill>
                 <a:latin typeface="Calibri"/>
               </a:rPr>
@@ -3511,7 +3511,7 @@
             <a:r>
               <a:rPr sz="1700" b="1">
                 <a:solidFill>
-                  <a:srgbClr val="75A7C6"/>
+                  <a:srgbClr val="12689E"/>
                 </a:solidFill>
                 <a:latin typeface="Calibri"/>
               </a:rPr>
@@ -3520,22 +3520,40 @@
           </a:p>
         </p:txBody>
       </p:sp>
-      <p:sp>
-        <p:nvSpPr>
-          <p:cNvPr id="5" name="Rectangle 4"/>
+    </p:spTree>
+  </p:cSld>
+  <p:clrMapOvr>
+    <a:masterClrMapping/>
+  </p:clrMapOvr>
+</p:sld>
+</file>
+
+<file path=ppt/slides/slide3.xml><?xml version="1.0" encoding="utf-8"?>
+<p:sld xmlns:a="http://schemas.openxmlformats.org/drawingml/2006/main" xmlns:p="http://schemas.openxmlformats.org/presentationml/2006/main" xmlns:r="http://schemas.openxmlformats.org/officeDocument/2006/relationships">
+  <p:cSld>
+    <p:spTree>
+      <p:nvGrpSpPr>
+        <p:cNvPr id="1" name=""/>
+        <p:cNvGrpSpPr/>
+        <p:nvPr/>
+      </p:nvGrpSpPr>
+      <p:grpSpPr/>
+      <p:sp>
+        <p:nvSpPr>
+          <p:cNvPr id="4" name="Rectangle 3"/>
           <p:cNvSpPr/>
           <p:nvPr/>
         </p:nvSpPr>
         <p:spPr>
           <a:xfrm>
-            <a:off x="658368" y="1261872"/>
-            <a:ext cx="3108960" cy="36576"/>
+            <a:off x="0" y="0"/>
+            <a:ext cx="12191695" cy="1051560"/>
           </a:xfrm>
           <a:prstGeom prst="rect">
             <a:avLst/>
           </a:prstGeom>
           <a:solidFill>
-            <a:srgbClr val="75A7C6"/>
+            <a:srgbClr val="12689E"/>
           </a:solidFill>
           <a:ln>
             <a:noFill/>
@@ -3564,93 +3582,31 @@
           </a:p>
         </p:txBody>
       </p:sp>
-    </p:spTree>
-  </p:cSld>
-  <p:clrMapOvr>
-    <a:masterClrMapping/>
-  </p:clrMapOvr>
-</p:sld>
-</file>
-
-<file path=ppt/slides/slide3.xml><?xml version="1.0" encoding="utf-8"?>
-<p:sld xmlns:a="http://schemas.openxmlformats.org/drawingml/2006/main" xmlns:p="http://schemas.openxmlformats.org/presentationml/2006/main" xmlns:r="http://schemas.openxmlformats.org/officeDocument/2006/relationships">
-  <p:cSld>
-    <p:spTree>
-      <p:nvGrpSpPr>
-        <p:cNvPr id="1" name=""/>
-        <p:cNvGrpSpPr/>
-        <p:nvPr/>
-      </p:nvGrpSpPr>
-      <p:grpSpPr/>
-      <p:sp>
-        <p:nvSpPr>
-          <p:cNvPr id="4" name="Rectangle 3"/>
-          <p:cNvSpPr/>
-          <p:nvPr/>
+      <p:sp>
+        <p:nvSpPr>
+          <p:cNvPr id="2" name="Title 1"/>
+          <p:cNvSpPr>
+            <a:spLocks noGrp="1"/>
+          </p:cNvSpPr>
+          <p:nvPr>
+            <p:ph type="title"/>
+          </p:nvPr>
         </p:nvSpPr>
         <p:spPr>
           <a:xfrm>
-            <a:off x="-45720" y="-45720"/>
-            <a:ext cx="12344400" cy="6949440"/>
-          </a:xfrm>
-          <a:prstGeom prst="rect">
-            <a:avLst/>
-          </a:prstGeom>
-          <a:solidFill>
-            <a:srgbClr val="1B2024"/>
-          </a:solidFill>
-          <a:ln>
-            <a:noFill/>
-          </a:ln>
-          <a:effectLst/>
-        </p:spPr>
-        <p:style>
-          <a:lnRef idx="1">
-            <a:schemeClr val="accent1"/>
-          </a:lnRef>
-          <a:fillRef idx="3">
-            <a:schemeClr val="accent1"/>
-          </a:fillRef>
-          <a:effectRef idx="2">
-            <a:schemeClr val="accent1"/>
-          </a:effectRef>
-          <a:fontRef idx="minor">
-            <a:schemeClr val="lt1"/>
-          </a:fontRef>
-        </p:style>
-        <p:txBody>
-          <a:bodyPr rtlCol="0" anchor="ctr"/>
-          <a:lstStyle/>
-          <a:p>
-            <a:pPr algn="ctr"/>
-          </a:p>
-        </p:txBody>
-      </p:sp>
-      <p:sp>
-        <p:nvSpPr>
-          <p:cNvPr id="2" name="Title 1"/>
-          <p:cNvSpPr>
-            <a:spLocks noGrp="1"/>
-          </p:cNvSpPr>
-          <p:nvPr>
-            <p:ph type="title"/>
-          </p:nvPr>
-        </p:nvSpPr>
-        <p:spPr>
-          <a:xfrm>
-            <a:off x="640080" y="384048"/>
-            <a:ext cx="10972800" cy="868680"/>
+            <a:off x="640080" y="0"/>
+            <a:ext cx="10972800" cy="1051560"/>
           </a:xfrm>
         </p:spPr>
         <p:txBody>
-          <a:bodyPr wrap="square" anchor="t"/>
+          <a:bodyPr wrap="square" anchor="ctr"/>
           <a:lstStyle/>
           <a:p>
             <a:pPr algn="l"/>
             <a:r>
-              <a:rPr b="1" sz="2700">
-                <a:solidFill>
-                  <a:srgbClr val="75A7C6"/>
+              <a:rPr b="1" sz="2400">
+                <a:solidFill>
+                  <a:srgbClr val="FFFFFF"/>
                 </a:solidFill>
                 <a:latin typeface="Century Gothic"/>
               </a:rPr>
@@ -3671,8 +3627,8 @@
         </p:nvSpPr>
         <p:spPr>
           <a:xfrm>
-            <a:off x="658368" y="1481328"/>
-            <a:ext cx="5760720" cy="4754880"/>
+            <a:off x="658368" y="1371600"/>
+            <a:ext cx="5760720" cy="4937760"/>
           </a:xfrm>
         </p:spPr>
         <p:txBody>
@@ -3689,7 +3645,7 @@
             <a:r>
               <a:rPr sz="1500" b="1">
                 <a:solidFill>
-                  <a:srgbClr val="75A7C6"/>
+                  <a:srgbClr val="12689E"/>
                 </a:solidFill>
                 <a:latin typeface="Calibri"/>
               </a:rPr>
@@ -3705,7 +3661,7 @@
             <a:r>
               <a:rPr sz="1300" b="0">
                 <a:solidFill>
-                  <a:srgbClr val="E6EBE8"/>
+                  <a:srgbClr val="232A26"/>
                 </a:solidFill>
                 <a:latin typeface="Calibri"/>
               </a:rPr>
@@ -3721,7 +3677,7 @@
             <a:r>
               <a:rPr sz="1500" b="1">
                 <a:solidFill>
-                  <a:srgbClr val="75A7C6"/>
+                  <a:srgbClr val="12689E"/>
                 </a:solidFill>
                 <a:latin typeface="Calibri"/>
               </a:rPr>
@@ -3737,7 +3693,7 @@
             <a:r>
               <a:rPr sz="1300" b="0">
                 <a:solidFill>
-                  <a:srgbClr val="E6EBE8"/>
+                  <a:srgbClr val="232A26"/>
                 </a:solidFill>
                 <a:latin typeface="Calibri"/>
               </a:rPr>
@@ -3753,7 +3709,7 @@
             <a:r>
               <a:rPr sz="1500" b="0">
                 <a:solidFill>
-                  <a:srgbClr val="E6EBE8"/>
+                  <a:srgbClr val="232A26"/>
                 </a:solidFill>
                 <a:latin typeface="Calibri"/>
               </a:rPr>
@@ -3769,7 +3725,7 @@
             <a:r>
               <a:rPr sz="1500" b="0">
                 <a:solidFill>
-                  <a:srgbClr val="E6EBE8"/>
+                  <a:srgbClr val="232A26"/>
                 </a:solidFill>
                 <a:latin typeface="Calibri"/>
               </a:rPr>
@@ -3778,53 +3734,9 @@
           </a:p>
         </p:txBody>
       </p:sp>
-      <p:sp>
-        <p:nvSpPr>
-          <p:cNvPr id="5" name="Rectangle 4"/>
-          <p:cNvSpPr/>
-          <p:nvPr/>
-        </p:nvSpPr>
-        <p:spPr>
-          <a:xfrm>
-            <a:off x="658368" y="1261872"/>
-            <a:ext cx="3108960" cy="36576"/>
-          </a:xfrm>
-          <a:prstGeom prst="rect">
-            <a:avLst/>
-          </a:prstGeom>
-          <a:solidFill>
-            <a:srgbClr val="75A7C6"/>
-          </a:solidFill>
-          <a:ln>
-            <a:noFill/>
-          </a:ln>
-          <a:effectLst/>
-        </p:spPr>
-        <p:style>
-          <a:lnRef idx="1">
-            <a:schemeClr val="accent1"/>
-          </a:lnRef>
-          <a:fillRef idx="3">
-            <a:schemeClr val="accent1"/>
-          </a:fillRef>
-          <a:effectRef idx="2">
-            <a:schemeClr val="accent1"/>
-          </a:effectRef>
-          <a:fontRef idx="minor">
-            <a:schemeClr val="lt1"/>
-          </a:fontRef>
-        </p:style>
-        <p:txBody>
-          <a:bodyPr rtlCol="0" anchor="ctr"/>
-          <a:lstStyle/>
-          <a:p>
-            <a:pPr algn="ctr"/>
-          </a:p>
-        </p:txBody>
-      </p:sp>
       <p:pic>
         <p:nvPicPr>
-          <p:cNvPr id="6" name="Picture 5" descr="topology.png"/>
+          <p:cNvPr id="5" name="Picture 4" descr="topology.png"/>
           <p:cNvPicPr>
             <a:picLocks noChangeAspect="1"/>
           </p:cNvPicPr>
@@ -3838,7 +3750,7 @@
         </p:blipFill>
         <p:spPr>
           <a:xfrm>
-            <a:off x="6629400" y="1872434"/>
+            <a:off x="6629400" y="1817570"/>
             <a:ext cx="5120640" cy="3862938"/>
           </a:xfrm>
           <a:prstGeom prst="rect">
@@ -3872,14 +3784,14 @@
         </p:nvSpPr>
         <p:spPr>
           <a:xfrm>
-            <a:off x="-45720" y="-45720"/>
-            <a:ext cx="12344400" cy="6949440"/>
+            <a:off x="0" y="0"/>
+            <a:ext cx="12191695" cy="1051560"/>
           </a:xfrm>
           <a:prstGeom prst="rect">
             <a:avLst/>
           </a:prstGeom>
           <a:solidFill>
-            <a:srgbClr val="1B2024"/>
+            <a:srgbClr val="12689E"/>
           </a:solidFill>
           <a:ln>
             <a:noFill/>
@@ -3920,19 +3832,19 @@
         </p:nvSpPr>
         <p:spPr>
           <a:xfrm>
-            <a:off x="640080" y="384048"/>
-            <a:ext cx="10972800" cy="868680"/>
+            <a:off x="640080" y="0"/>
+            <a:ext cx="10972800" cy="1051560"/>
           </a:xfrm>
         </p:spPr>
         <p:txBody>
-          <a:bodyPr wrap="square" anchor="t"/>
+          <a:bodyPr wrap="square" anchor="ctr"/>
           <a:lstStyle/>
           <a:p>
             <a:pPr algn="l"/>
             <a:r>
-              <a:rPr b="1" sz="2700">
-                <a:solidFill>
-                  <a:srgbClr val="75A7C6"/>
+              <a:rPr b="1" sz="2400">
+                <a:solidFill>
+                  <a:srgbClr val="FFFFFF"/>
                 </a:solidFill>
                 <a:latin typeface="Century Gothic"/>
               </a:rPr>
@@ -3953,8 +3865,8 @@
         </p:nvSpPr>
         <p:spPr>
           <a:xfrm>
-            <a:off x="658368" y="1481328"/>
-            <a:ext cx="5760720" cy="4754880"/>
+            <a:off x="658368" y="1371600"/>
+            <a:ext cx="5760720" cy="4937760"/>
           </a:xfrm>
         </p:spPr>
         <p:txBody>
@@ -3971,7 +3883,7 @@
             <a:r>
               <a:rPr sz="1500" b="0">
                 <a:solidFill>
-                  <a:srgbClr val="E6EBE8"/>
+                  <a:srgbClr val="232A26"/>
                 </a:solidFill>
                 <a:latin typeface="Calibri"/>
               </a:rPr>
@@ -3987,7 +3899,7 @@
             <a:r>
               <a:rPr sz="1500" b="1">
                 <a:solidFill>
-                  <a:srgbClr val="75A7C6"/>
+                  <a:srgbClr val="12689E"/>
                 </a:solidFill>
                 <a:latin typeface="Calibri"/>
               </a:rPr>
@@ -4003,7 +3915,7 @@
             <a:r>
               <a:rPr sz="1500" b="0">
                 <a:solidFill>
-                  <a:srgbClr val="E6EBE8"/>
+                  <a:srgbClr val="232A26"/>
                 </a:solidFill>
                 <a:latin typeface="Calibri"/>
               </a:rPr>
@@ -4019,7 +3931,7 @@
             <a:r>
               <a:rPr sz="1500" b="0">
                 <a:solidFill>
-                  <a:srgbClr val="E6EBE8"/>
+                  <a:srgbClr val="232A26"/>
                 </a:solidFill>
                 <a:latin typeface="Calibri"/>
               </a:rPr>
@@ -4028,53 +3940,9 @@
           </a:p>
         </p:txBody>
       </p:sp>
-      <p:sp>
-        <p:nvSpPr>
-          <p:cNvPr id="5" name="Rectangle 4"/>
-          <p:cNvSpPr/>
-          <p:nvPr/>
-        </p:nvSpPr>
-        <p:spPr>
-          <a:xfrm>
-            <a:off x="658368" y="1261872"/>
-            <a:ext cx="3108960" cy="36576"/>
-          </a:xfrm>
-          <a:prstGeom prst="rect">
-            <a:avLst/>
-          </a:prstGeom>
-          <a:solidFill>
-            <a:srgbClr val="75A7C6"/>
-          </a:solidFill>
-          <a:ln>
-            <a:noFill/>
-          </a:ln>
-          <a:effectLst/>
-        </p:spPr>
-        <p:style>
-          <a:lnRef idx="1">
-            <a:schemeClr val="accent1"/>
-          </a:lnRef>
-          <a:fillRef idx="3">
-            <a:schemeClr val="accent1"/>
-          </a:fillRef>
-          <a:effectRef idx="2">
-            <a:schemeClr val="accent1"/>
-          </a:effectRef>
-          <a:fontRef idx="minor">
-            <a:schemeClr val="lt1"/>
-          </a:fontRef>
-        </p:style>
-        <p:txBody>
-          <a:bodyPr rtlCol="0" anchor="ctr"/>
-          <a:lstStyle/>
-          <a:p>
-            <a:pPr algn="ctr"/>
-          </a:p>
-        </p:txBody>
-      </p:sp>
       <p:pic>
         <p:nvPicPr>
-          <p:cNvPr id="6" name="Picture 5" descr="dashboard.png"/>
+          <p:cNvPr id="5" name="Picture 4" descr="dashboard.png"/>
           <p:cNvPicPr>
             <a:picLocks noChangeAspect="1"/>
           </p:cNvPicPr>
@@ -4088,7 +3956,7 @@
         </p:blipFill>
         <p:spPr>
           <a:xfrm>
-            <a:off x="6629400" y="1883663"/>
+            <a:off x="6629400" y="1828799"/>
             <a:ext cx="5120640" cy="3840480"/>
           </a:xfrm>
           <a:prstGeom prst="rect">
@@ -4122,14 +3990,14 @@
         </p:nvSpPr>
         <p:spPr>
           <a:xfrm>
-            <a:off x="-45720" y="-45720"/>
-            <a:ext cx="12344400" cy="6949440"/>
+            <a:off x="0" y="0"/>
+            <a:ext cx="12191695" cy="1051560"/>
           </a:xfrm>
           <a:prstGeom prst="rect">
             <a:avLst/>
           </a:prstGeom>
           <a:solidFill>
-            <a:srgbClr val="1B2024"/>
+            <a:srgbClr val="12689E"/>
           </a:solidFill>
           <a:ln>
             <a:noFill/>
@@ -4170,19 +4038,19 @@
         </p:nvSpPr>
         <p:spPr>
           <a:xfrm>
-            <a:off x="640080" y="384048"/>
-            <a:ext cx="10972800" cy="868680"/>
+            <a:off x="640080" y="0"/>
+            <a:ext cx="10972800" cy="1051560"/>
           </a:xfrm>
         </p:spPr>
         <p:txBody>
-          <a:bodyPr wrap="square" anchor="t"/>
+          <a:bodyPr wrap="square" anchor="ctr"/>
           <a:lstStyle/>
           <a:p>
             <a:pPr algn="l"/>
             <a:r>
-              <a:rPr b="1" sz="2700">
-                <a:solidFill>
-                  <a:srgbClr val="75A7C6"/>
+              <a:rPr b="1" sz="2400">
+                <a:solidFill>
+                  <a:srgbClr val="FFFFFF"/>
                 </a:solidFill>
                 <a:latin typeface="Century Gothic"/>
               </a:rPr>
@@ -4203,8 +4071,8 @@
         </p:nvSpPr>
         <p:spPr>
           <a:xfrm>
-            <a:off x="658368" y="1481328"/>
-            <a:ext cx="10972800" cy="4846320"/>
+            <a:off x="658368" y="1371600"/>
+            <a:ext cx="10972800" cy="5029200"/>
           </a:xfrm>
         </p:spPr>
         <p:txBody>
@@ -4221,7 +4089,7 @@
             <a:r>
               <a:rPr sz="1700" b="1">
                 <a:solidFill>
-                  <a:srgbClr val="75A7C6"/>
+                  <a:srgbClr val="12689E"/>
                 </a:solidFill>
                 <a:latin typeface="Calibri"/>
               </a:rPr>
@@ -4237,7 +4105,7 @@
             <a:r>
               <a:rPr sz="1500" b="0">
                 <a:solidFill>
-                  <a:srgbClr val="E6EBE8"/>
+                  <a:srgbClr val="232A26"/>
                 </a:solidFill>
                 <a:latin typeface="Calibri"/>
               </a:rPr>
@@ -4253,7 +4121,7 @@
             <a:r>
               <a:rPr sz="1700" b="1">
                 <a:solidFill>
-                  <a:srgbClr val="75A7C6"/>
+                  <a:srgbClr val="12689E"/>
                 </a:solidFill>
                 <a:latin typeface="Calibri"/>
               </a:rPr>
@@ -4269,7 +4137,7 @@
             <a:r>
               <a:rPr sz="1500" b="0">
                 <a:solidFill>
-                  <a:srgbClr val="E6EBE8"/>
+                  <a:srgbClr val="232A26"/>
                 </a:solidFill>
                 <a:latin typeface="Calibri"/>
               </a:rPr>
@@ -4285,7 +4153,7 @@
             <a:r>
               <a:rPr sz="1700" b="1">
                 <a:solidFill>
-                  <a:srgbClr val="75A7C6"/>
+                  <a:srgbClr val="12689E"/>
                 </a:solidFill>
                 <a:latin typeface="Calibri"/>
               </a:rPr>
@@ -4301,7 +4169,7 @@
             <a:r>
               <a:rPr sz="1500" b="0">
                 <a:solidFill>
-                  <a:srgbClr val="E6EBE8"/>
+                  <a:srgbClr val="232A26"/>
                 </a:solidFill>
                 <a:latin typeface="Calibri"/>
               </a:rPr>
@@ -4317,7 +4185,7 @@
             <a:r>
               <a:rPr sz="1700" b="0">
                 <a:solidFill>
-                  <a:srgbClr val="E6EBE8"/>
+                  <a:srgbClr val="232A26"/>
                 </a:solidFill>
                 <a:latin typeface="Calibri"/>
               </a:rPr>
@@ -4326,22 +4194,40 @@
           </a:p>
         </p:txBody>
       </p:sp>
-      <p:sp>
-        <p:nvSpPr>
-          <p:cNvPr id="5" name="Rectangle 4"/>
+    </p:spTree>
+  </p:cSld>
+  <p:clrMapOvr>
+    <a:masterClrMapping/>
+  </p:clrMapOvr>
+</p:sld>
+</file>
+
+<file path=ppt/slides/slide6.xml><?xml version="1.0" encoding="utf-8"?>
+<p:sld xmlns:a="http://schemas.openxmlformats.org/drawingml/2006/main" xmlns:p="http://schemas.openxmlformats.org/presentationml/2006/main" xmlns:r="http://schemas.openxmlformats.org/officeDocument/2006/relationships">
+  <p:cSld>
+    <p:spTree>
+      <p:nvGrpSpPr>
+        <p:cNvPr id="1" name=""/>
+        <p:cNvGrpSpPr/>
+        <p:nvPr/>
+      </p:nvGrpSpPr>
+      <p:grpSpPr/>
+      <p:sp>
+        <p:nvSpPr>
+          <p:cNvPr id="4" name="Rectangle 3"/>
           <p:cNvSpPr/>
           <p:nvPr/>
         </p:nvSpPr>
         <p:spPr>
           <a:xfrm>
-            <a:off x="658368" y="1261872"/>
-            <a:ext cx="3108960" cy="36576"/>
+            <a:off x="0" y="0"/>
+            <a:ext cx="12191695" cy="1051560"/>
           </a:xfrm>
           <a:prstGeom prst="rect">
             <a:avLst/>
           </a:prstGeom>
           <a:solidFill>
-            <a:srgbClr val="75A7C6"/>
+            <a:srgbClr val="12689E"/>
           </a:solidFill>
           <a:ln>
             <a:noFill/>
@@ -4370,93 +4256,31 @@
           </a:p>
         </p:txBody>
       </p:sp>
-    </p:spTree>
-  </p:cSld>
-  <p:clrMapOvr>
-    <a:masterClrMapping/>
-  </p:clrMapOvr>
-</p:sld>
-</file>
-
-<file path=ppt/slides/slide6.xml><?xml version="1.0" encoding="utf-8"?>
-<p:sld xmlns:a="http://schemas.openxmlformats.org/drawingml/2006/main" xmlns:p="http://schemas.openxmlformats.org/presentationml/2006/main" xmlns:r="http://schemas.openxmlformats.org/officeDocument/2006/relationships">
-  <p:cSld>
-    <p:spTree>
-      <p:nvGrpSpPr>
-        <p:cNvPr id="1" name=""/>
-        <p:cNvGrpSpPr/>
-        <p:nvPr/>
-      </p:nvGrpSpPr>
-      <p:grpSpPr/>
-      <p:sp>
-        <p:nvSpPr>
-          <p:cNvPr id="4" name="Rectangle 3"/>
-          <p:cNvSpPr/>
-          <p:nvPr/>
+      <p:sp>
+        <p:nvSpPr>
+          <p:cNvPr id="2" name="Title 1"/>
+          <p:cNvSpPr>
+            <a:spLocks noGrp="1"/>
+          </p:cNvSpPr>
+          <p:nvPr>
+            <p:ph type="title"/>
+          </p:nvPr>
         </p:nvSpPr>
         <p:spPr>
           <a:xfrm>
-            <a:off x="-45720" y="-45720"/>
-            <a:ext cx="12344400" cy="6949440"/>
-          </a:xfrm>
-          <a:prstGeom prst="rect">
-            <a:avLst/>
-          </a:prstGeom>
-          <a:solidFill>
-            <a:srgbClr val="1B2024"/>
-          </a:solidFill>
-          <a:ln>
-            <a:noFill/>
-          </a:ln>
-          <a:effectLst/>
-        </p:spPr>
-        <p:style>
-          <a:lnRef idx="1">
-            <a:schemeClr val="accent1"/>
-          </a:lnRef>
-          <a:fillRef idx="3">
-            <a:schemeClr val="accent1"/>
-          </a:fillRef>
-          <a:effectRef idx="2">
-            <a:schemeClr val="accent1"/>
-          </a:effectRef>
-          <a:fontRef idx="minor">
-            <a:schemeClr val="lt1"/>
-          </a:fontRef>
-        </p:style>
-        <p:txBody>
-          <a:bodyPr rtlCol="0" anchor="ctr"/>
-          <a:lstStyle/>
-          <a:p>
-            <a:pPr algn="ctr"/>
-          </a:p>
-        </p:txBody>
-      </p:sp>
-      <p:sp>
-        <p:nvSpPr>
-          <p:cNvPr id="2" name="Title 1"/>
-          <p:cNvSpPr>
-            <a:spLocks noGrp="1"/>
-          </p:cNvSpPr>
-          <p:nvPr>
-            <p:ph type="title"/>
-          </p:nvPr>
-        </p:nvSpPr>
-        <p:spPr>
-          <a:xfrm>
-            <a:off x="640080" y="384048"/>
-            <a:ext cx="10972800" cy="868680"/>
+            <a:off x="640080" y="0"/>
+            <a:ext cx="10972800" cy="1051560"/>
           </a:xfrm>
         </p:spPr>
         <p:txBody>
-          <a:bodyPr wrap="square" anchor="t"/>
+          <a:bodyPr wrap="square" anchor="ctr"/>
           <a:lstStyle/>
           <a:p>
             <a:pPr algn="l"/>
             <a:r>
-              <a:rPr b="1" sz="2700">
-                <a:solidFill>
-                  <a:srgbClr val="75A7C6"/>
+              <a:rPr b="1" sz="2400">
+                <a:solidFill>
+                  <a:srgbClr val="FFFFFF"/>
                 </a:solidFill>
                 <a:latin typeface="Century Gothic"/>
               </a:rPr>
@@ -4477,8 +4301,8 @@
         </p:nvSpPr>
         <p:spPr>
           <a:xfrm>
-            <a:off x="658368" y="1481328"/>
-            <a:ext cx="10972800" cy="4846320"/>
+            <a:off x="658368" y="1371600"/>
+            <a:ext cx="10972800" cy="5029200"/>
           </a:xfrm>
         </p:spPr>
         <p:txBody>
@@ -4495,7 +4319,7 @@
             <a:r>
               <a:rPr sz="1700" b="0">
                 <a:solidFill>
-                  <a:srgbClr val="E6EBE8"/>
+                  <a:srgbClr val="232A26"/>
                 </a:solidFill>
                 <a:latin typeface="Calibri"/>
               </a:rPr>
@@ -4511,7 +4335,7 @@
             <a:r>
               <a:rPr sz="1700" b="0">
                 <a:solidFill>
-                  <a:srgbClr val="E6EBE8"/>
+                  <a:srgbClr val="232A26"/>
                 </a:solidFill>
                 <a:latin typeface="Calibri"/>
               </a:rPr>
@@ -4527,7 +4351,7 @@
             <a:r>
               <a:rPr sz="1700" b="1">
                 <a:solidFill>
-                  <a:srgbClr val="75A7C6"/>
+                  <a:srgbClr val="12689E"/>
                 </a:solidFill>
                 <a:latin typeface="Calibri"/>
               </a:rPr>
@@ -4543,56 +4367,12 @@
             <a:r>
               <a:rPr sz="1700" b="0">
                 <a:solidFill>
-                  <a:srgbClr val="E6EBE8"/>
+                  <a:srgbClr val="232A26"/>
                 </a:solidFill>
                 <a:latin typeface="Calibri"/>
               </a:rPr>
               <a:t>Thank you. Questions?</a:t>
             </a:r>
-          </a:p>
-        </p:txBody>
-      </p:sp>
-      <p:sp>
-        <p:nvSpPr>
-          <p:cNvPr id="5" name="Rectangle 4"/>
-          <p:cNvSpPr/>
-          <p:nvPr/>
-        </p:nvSpPr>
-        <p:spPr>
-          <a:xfrm>
-            <a:off x="658368" y="1261872"/>
-            <a:ext cx="3108960" cy="36576"/>
-          </a:xfrm>
-          <a:prstGeom prst="rect">
-            <a:avLst/>
-          </a:prstGeom>
-          <a:solidFill>
-            <a:srgbClr val="75A7C6"/>
-          </a:solidFill>
-          <a:ln>
-            <a:noFill/>
-          </a:ln>
-          <a:effectLst/>
-        </p:spPr>
-        <p:style>
-          <a:lnRef idx="1">
-            <a:schemeClr val="accent1"/>
-          </a:lnRef>
-          <a:fillRef idx="3">
-            <a:schemeClr val="accent1"/>
-          </a:fillRef>
-          <a:effectRef idx="2">
-            <a:schemeClr val="accent1"/>
-          </a:effectRef>
-          <a:fontRef idx="minor">
-            <a:schemeClr val="lt1"/>
-          </a:fontRef>
-        </p:style>
-        <p:txBody>
-          <a:bodyPr rtlCol="0" anchor="ctr"/>
-          <a:lstStyle/>
-          <a:p>
-            <a:pPr algn="ctr"/>
           </a:p>
         </p:txBody>
       </p:sp>

</xml_diff>